<commit_message>
Correct source repository in pitch deck
</commit_message>
<xml_diff>
--- a/docs/pitch-deck.pptx
+++ b/docs/pitch-deck.pptx
@@ -2,18 +2,18 @@
 <file path=ppt/presentation.xml><?xml version="1.0" encoding="utf-8"?>
 <p:presentation xmlns:p="http://schemas.openxmlformats.org/presentationml/2006/main">
   <p:sldMasterIdLst>
-    <p:sldMasterId xmlns:r="http://schemas.openxmlformats.org/officeDocument/2006/relationships" id="2147483648" r:id="R111f87cdc2b34d40"/>
+    <p:sldMasterId xmlns:r="http://schemas.openxmlformats.org/officeDocument/2006/relationships" id="2147483648" r:id="R080e7c7dcd6e4cc9"/>
   </p:sldMasterIdLst>
   <p:notesMasterIdLst>
-    <p:notesMasterId xmlns:r="http://schemas.openxmlformats.org/officeDocument/2006/relationships" r:id="R035f15aaf0ec4120"/>
+    <p:notesMasterId xmlns:r="http://schemas.openxmlformats.org/officeDocument/2006/relationships" r:id="R96a8bb1d111643f5"/>
   </p:notesMasterIdLst>
   <p:sldIdLst>
-    <p:sldId xmlns:r="http://schemas.openxmlformats.org/officeDocument/2006/relationships" id="256" r:id="R2bc260bb09e14ac9"/>
-    <p:sldId xmlns:r="http://schemas.openxmlformats.org/officeDocument/2006/relationships" id="257" r:id="Ra9c5810f829a477d"/>
-    <p:sldId xmlns:r="http://schemas.openxmlformats.org/officeDocument/2006/relationships" id="258" r:id="R4cac9dce35574c29"/>
-    <p:sldId xmlns:r="http://schemas.openxmlformats.org/officeDocument/2006/relationships" id="259" r:id="R7403279548ad459a"/>
-    <p:sldId xmlns:r="http://schemas.openxmlformats.org/officeDocument/2006/relationships" id="260" r:id="Rabf2b1c3ec814439"/>
-    <p:sldId xmlns:r="http://schemas.openxmlformats.org/officeDocument/2006/relationships" id="261" r:id="R30a2ff4edd244f39"/>
+    <p:sldId xmlns:r="http://schemas.openxmlformats.org/officeDocument/2006/relationships" id="256" r:id="R357c9bf57f774a0d"/>
+    <p:sldId xmlns:r="http://schemas.openxmlformats.org/officeDocument/2006/relationships" id="257" r:id="Ra669344a228646e0"/>
+    <p:sldId xmlns:r="http://schemas.openxmlformats.org/officeDocument/2006/relationships" id="258" r:id="Rb8bdebf9821b4261"/>
+    <p:sldId xmlns:r="http://schemas.openxmlformats.org/officeDocument/2006/relationships" id="259" r:id="R41b0c9c32c544477"/>
+    <p:sldId xmlns:r="http://schemas.openxmlformats.org/officeDocument/2006/relationships" id="260" r:id="R8239331d588f4376"/>
+    <p:sldId xmlns:r="http://schemas.openxmlformats.org/officeDocument/2006/relationships" id="261" r:id="Re7f46a48302d4b8f"/>
   </p:sldIdLst>
   <p:sldSz cx="12192000" cy="6858000"/>
   <p:notesSz cx="6858000" cy="9144000"/>
@@ -797,7 +797,7 @@
           <a:lstStyle xmlns:a="http://schemas.openxmlformats.org/drawingml/2006/main"/>
           <a:p xmlns:a="http://schemas.openxmlformats.org/drawingml/2006/main">
             <a:r>
-              <a:t>No interviews, active-user metrics, business savings or security audit are claimed. Public source: https://github.com/xiehuanyi/permitscope . OpenAI Codex assisted research, code, tests, UI and docs. OpenZeppelin and EthereumJS provide the core token and execution dependencies.</a:t>
+              <a:t>No interviews, active-user metrics, business savings or security audit are claimed. Public source: https://github.com/bigerbigernerd/permitscope . OpenAI Codex assisted research, code, tests, UI and docs. OpenZeppelin and EthereumJS provide the core token and execution dependencies.</a:t>
             </a:r>
           </a:p>
         </p:txBody>
@@ -865,7 +865,7 @@
   </p:cSld>
   <p:clrMap bg1="lt1" tx1="dk1" bg2="lt2" tx2="dk2" accent1="accent1" accent2="accent2" accent3="accent3" accent4="accent4" accent5="accent5" accent6="accent6" hlink="hlink" folHlink="folHlink"/>
   <p:sldLayoutIdLst>
-    <p:sldLayoutId xmlns:r="http://schemas.openxmlformats.org/officeDocument/2006/relationships" id="2147483649" r:id="R368f6def484147ac"/>
+    <p:sldLayoutId xmlns:r="http://schemas.openxmlformats.org/officeDocument/2006/relationships" id="2147483649" r:id="Refa104c0693b40c9"/>
   </p:sldLayoutIdLst>
   <p:txStyles>
     <p:titleStyle>
@@ -1416,7 +1416,7 @@
           <p:cNvPr id="6" name="">
             <a:extLst xmlns:a="http://schemas.openxmlformats.org/drawingml/2006/main">
               <a:ext uri="{FF2B5EF4-FFF2-40B4-BE49-F238E27FC236}">
-                <a16:creationId xmlns:a16="http://schemas.microsoft.com/office/drawing/2014/main" id="{89B04A76-239E-495D-B5E2-627911F98B9D}"/>
+                <a16:creationId xmlns:a16="http://schemas.microsoft.com/office/drawing/2014/main" id="{FDA31E4B-5B48-4E41-87BD-A0310D24AA1A}"/>
               </a:ext>
             </a:extLst>
           </p:cNvPr>
@@ -1473,7 +1473,7 @@
           <p:cNvPr id="2" name="">
             <a:extLst xmlns:a="http://schemas.openxmlformats.org/drawingml/2006/main">
               <a:ext uri="{FF2B5EF4-FFF2-40B4-BE49-F238E27FC236}">
-                <a16:creationId xmlns:a16="http://schemas.microsoft.com/office/drawing/2014/main" id="{702B9CF4-25BE-49CF-AAE2-5892D9777DFF}"/>
+                <a16:creationId xmlns:a16="http://schemas.microsoft.com/office/drawing/2014/main" id="{D63719DC-43A2-4043-A6D9-57B34BC3E3D1}"/>
               </a:ext>
             </a:extLst>
           </p:cNvPr>
@@ -1530,7 +1530,7 @@
           <p:cNvPr id="3" name="">
             <a:extLst xmlns:a="http://schemas.openxmlformats.org/drawingml/2006/main">
               <a:ext uri="{FF2B5EF4-FFF2-40B4-BE49-F238E27FC236}">
-                <a16:creationId xmlns:a16="http://schemas.microsoft.com/office/drawing/2014/main" id="{933F65F5-C7CA-4862-973B-B6B4ABC4702E}"/>
+                <a16:creationId xmlns:a16="http://schemas.microsoft.com/office/drawing/2014/main" id="{52107879-E7B7-4AB4-BFE0-E84330C79ECD}"/>
               </a:ext>
             </a:extLst>
           </p:cNvPr>
@@ -1610,7 +1610,7 @@
           <p:cNvPr id="4" name="">
             <a:extLst xmlns:a="http://schemas.openxmlformats.org/drawingml/2006/main">
               <a:ext uri="{FF2B5EF4-FFF2-40B4-BE49-F238E27FC236}">
-                <a16:creationId xmlns:a16="http://schemas.microsoft.com/office/drawing/2014/main" id="{18B3B9E2-53BF-4F37-88D0-3607CA0C2842}"/>
+                <a16:creationId xmlns:a16="http://schemas.microsoft.com/office/drawing/2014/main" id="{C4388130-062F-4383-8B98-A201C4511BD5}"/>
               </a:ext>
             </a:extLst>
           </p:cNvPr>
@@ -1690,7 +1690,7 @@
           <p:cNvPr id="5" name="">
             <a:extLst xmlns:a="http://schemas.openxmlformats.org/drawingml/2006/main">
               <a:ext uri="{FF2B5EF4-FFF2-40B4-BE49-F238E27FC236}">
-                <a16:creationId xmlns:a16="http://schemas.microsoft.com/office/drawing/2014/main" id="{49C803E1-BEB5-4168-A3AF-2088B9502346}"/>
+                <a16:creationId xmlns:a16="http://schemas.microsoft.com/office/drawing/2014/main" id="{D336F48C-52CD-4F87-8D3E-C44838FCF2B1}"/>
               </a:ext>
             </a:extLst>
           </p:cNvPr>
@@ -1745,7 +1745,7 @@
     </p:spTree>
     <p:extLst>
       <p:ext uri="{BB962C8B-B14F-4D97-AF65-F5344CB8AC3E}">
-        <p14:creationId xmlns:p14="http://schemas.microsoft.com/office/powerpoint/2010/main" val="287434050"/>
+        <p14:creationId xmlns:p14="http://schemas.microsoft.com/office/powerpoint/2010/main" val="443946069"/>
       </p:ext>
     </p:extLst>
   </p:cSld>
@@ -1776,7 +1776,7 @@
           <p:cNvPr id="6" name="">
             <a:extLst xmlns:a="http://schemas.openxmlformats.org/drawingml/2006/main">
               <a:ext uri="{FF2B5EF4-FFF2-40B4-BE49-F238E27FC236}">
-                <a16:creationId xmlns:a16="http://schemas.microsoft.com/office/drawing/2014/main" id="{3573363D-1EB7-4E0F-B16E-6F333EEADA35}"/>
+                <a16:creationId xmlns:a16="http://schemas.microsoft.com/office/drawing/2014/main" id="{F597DF92-D1D8-4010-9EF0-2285BED68338}"/>
               </a:ext>
             </a:extLst>
           </p:cNvPr>
@@ -1833,7 +1833,7 @@
           <p:cNvPr id="2" name="">
             <a:extLst xmlns:a="http://schemas.openxmlformats.org/drawingml/2006/main">
               <a:ext uri="{FF2B5EF4-FFF2-40B4-BE49-F238E27FC236}">
-                <a16:creationId xmlns:a16="http://schemas.microsoft.com/office/drawing/2014/main" id="{60D58E7E-7323-4A13-862B-7B0E20CB1C5E}"/>
+                <a16:creationId xmlns:a16="http://schemas.microsoft.com/office/drawing/2014/main" id="{C1750CC9-3C6B-42F6-B974-BDA70453529C}"/>
               </a:ext>
             </a:extLst>
           </p:cNvPr>
@@ -1890,7 +1890,7 @@
           <p:cNvPr id="3" name="">
             <a:extLst xmlns:a="http://schemas.openxmlformats.org/drawingml/2006/main">
               <a:ext uri="{FF2B5EF4-FFF2-40B4-BE49-F238E27FC236}">
-                <a16:creationId xmlns:a16="http://schemas.microsoft.com/office/drawing/2014/main" id="{D83CB34F-E8CF-43C2-AD7C-B02126ABF1BA}"/>
+                <a16:creationId xmlns:a16="http://schemas.microsoft.com/office/drawing/2014/main" id="{9E56D160-FEEC-432E-9B05-B095B083A828}"/>
               </a:ext>
             </a:extLst>
           </p:cNvPr>
@@ -1993,7 +1993,7 @@
           <p:cNvPr id="4" name="">
             <a:extLst xmlns:a="http://schemas.openxmlformats.org/drawingml/2006/main">
               <a:ext uri="{FF2B5EF4-FFF2-40B4-BE49-F238E27FC236}">
-                <a16:creationId xmlns:a16="http://schemas.microsoft.com/office/drawing/2014/main" id="{FA1FA558-16C2-4DAF-B82B-9C3345D879FC}"/>
+                <a16:creationId xmlns:a16="http://schemas.microsoft.com/office/drawing/2014/main" id="{047DCE77-75B6-43CC-85AF-2FE16D6B57D9}"/>
               </a:ext>
             </a:extLst>
           </p:cNvPr>
@@ -2050,7 +2050,7 @@
           <p:cNvPr id="5" name="">
             <a:extLst xmlns:a="http://schemas.openxmlformats.org/drawingml/2006/main">
               <a:ext uri="{FF2B5EF4-FFF2-40B4-BE49-F238E27FC236}">
-                <a16:creationId xmlns:a16="http://schemas.microsoft.com/office/drawing/2014/main" id="{88D9EDDC-0F06-4261-8913-67C087922931}"/>
+                <a16:creationId xmlns:a16="http://schemas.microsoft.com/office/drawing/2014/main" id="{69BC297D-4CCB-4E48-9800-CECA3DA0656D}"/>
               </a:ext>
             </a:extLst>
           </p:cNvPr>
@@ -2105,7 +2105,7 @@
     </p:spTree>
     <p:extLst>
       <p:ext uri="{BB962C8B-B14F-4D97-AF65-F5344CB8AC3E}">
-        <p14:creationId xmlns:p14="http://schemas.microsoft.com/office/powerpoint/2010/main" val="395346630"/>
+        <p14:creationId xmlns:p14="http://schemas.microsoft.com/office/powerpoint/2010/main" val="694457666"/>
       </p:ext>
     </p:extLst>
   </p:cSld>
@@ -2136,7 +2136,7 @@
           <p:cNvPr id="6" name="">
             <a:extLst xmlns:a="http://schemas.openxmlformats.org/drawingml/2006/main">
               <a:ext uri="{FF2B5EF4-FFF2-40B4-BE49-F238E27FC236}">
-                <a16:creationId xmlns:a16="http://schemas.microsoft.com/office/drawing/2014/main" id="{67AD6D6A-3A37-401A-81A4-FCAC8A3939CC}"/>
+                <a16:creationId xmlns:a16="http://schemas.microsoft.com/office/drawing/2014/main" id="{61A007DC-64E9-45E2-8FF6-09988FFDC629}"/>
               </a:ext>
             </a:extLst>
           </p:cNvPr>
@@ -2193,7 +2193,7 @@
           <p:cNvPr id="2" name="">
             <a:extLst xmlns:a="http://schemas.openxmlformats.org/drawingml/2006/main">
               <a:ext uri="{FF2B5EF4-FFF2-40B4-BE49-F238E27FC236}">
-                <a16:creationId xmlns:a16="http://schemas.microsoft.com/office/drawing/2014/main" id="{FCAB11F1-DB7C-4F97-BF3A-1E2B853719C2}"/>
+                <a16:creationId xmlns:a16="http://schemas.microsoft.com/office/drawing/2014/main" id="{E7FA849F-0A41-443D-AFA4-58E289ABB915}"/>
               </a:ext>
             </a:extLst>
           </p:cNvPr>
@@ -2250,7 +2250,7 @@
           <p:cNvPr id="3" name="">
             <a:extLst xmlns:a="http://schemas.openxmlformats.org/drawingml/2006/main">
               <a:ext uri="{FF2B5EF4-FFF2-40B4-BE49-F238E27FC236}">
-                <a16:creationId xmlns:a16="http://schemas.microsoft.com/office/drawing/2014/main" id="{5A6004A9-8EAC-4443-B7BA-F7E8AA274050}"/>
+                <a16:creationId xmlns:a16="http://schemas.microsoft.com/office/drawing/2014/main" id="{AF75443B-0F3C-400B-B720-3801E1B49E0D}"/>
               </a:ext>
             </a:extLst>
           </p:cNvPr>
@@ -2353,7 +2353,7 @@
           <p:cNvPr id="4" name="">
             <a:extLst xmlns:a="http://schemas.openxmlformats.org/drawingml/2006/main">
               <a:ext uri="{FF2B5EF4-FFF2-40B4-BE49-F238E27FC236}">
-                <a16:creationId xmlns:a16="http://schemas.microsoft.com/office/drawing/2014/main" id="{983C8AC3-24BF-4219-A884-94E158448A42}"/>
+                <a16:creationId xmlns:a16="http://schemas.microsoft.com/office/drawing/2014/main" id="{AFE33121-E5E0-401F-9C7D-3EDEB91CC801}"/>
               </a:ext>
             </a:extLst>
           </p:cNvPr>
@@ -2410,7 +2410,7 @@
           <p:cNvPr id="5" name="">
             <a:extLst xmlns:a="http://schemas.openxmlformats.org/drawingml/2006/main">
               <a:ext uri="{FF2B5EF4-FFF2-40B4-BE49-F238E27FC236}">
-                <a16:creationId xmlns:a16="http://schemas.microsoft.com/office/drawing/2014/main" id="{F46C3E8D-9D15-4B68-BB59-EC6F2017B46C}"/>
+                <a16:creationId xmlns:a16="http://schemas.microsoft.com/office/drawing/2014/main" id="{2CBA1B43-CA32-497C-A56E-8BFB6BBB98DE}"/>
               </a:ext>
             </a:extLst>
           </p:cNvPr>
@@ -2465,7 +2465,7 @@
     </p:spTree>
     <p:extLst>
       <p:ext uri="{BB962C8B-B14F-4D97-AF65-F5344CB8AC3E}">
-        <p14:creationId xmlns:p14="http://schemas.microsoft.com/office/powerpoint/2010/main" val="1284871315"/>
+        <p14:creationId xmlns:p14="http://schemas.microsoft.com/office/powerpoint/2010/main" val="690025268"/>
       </p:ext>
     </p:extLst>
   </p:cSld>
@@ -2496,7 +2496,7 @@
           <p:cNvPr id="5" name="">
             <a:extLst xmlns:a="http://schemas.openxmlformats.org/drawingml/2006/main">
               <a:ext uri="{FF2B5EF4-FFF2-40B4-BE49-F238E27FC236}">
-                <a16:creationId xmlns:a16="http://schemas.microsoft.com/office/drawing/2014/main" id="{02872911-5CF4-46D3-9785-0E98093BBD29}"/>
+                <a16:creationId xmlns:a16="http://schemas.microsoft.com/office/drawing/2014/main" id="{159F6F49-DDB3-442D-AAD5-8990E4A22B55}"/>
               </a:ext>
             </a:extLst>
           </p:cNvPr>
@@ -2553,7 +2553,7 @@
           <p:cNvPr id="2" name="">
             <a:extLst xmlns:a="http://schemas.openxmlformats.org/drawingml/2006/main">
               <a:ext uri="{FF2B5EF4-FFF2-40B4-BE49-F238E27FC236}">
-                <a16:creationId xmlns:a16="http://schemas.microsoft.com/office/drawing/2014/main" id="{61D12030-4A39-484A-83B7-A50D636C132A}"/>
+                <a16:creationId xmlns:a16="http://schemas.microsoft.com/office/drawing/2014/main" id="{CAE3E07E-BE17-4F76-A636-CE7A87CE5EA5}"/>
               </a:ext>
             </a:extLst>
           </p:cNvPr>
@@ -2610,7 +2610,7 @@
           <p:cNvPr id="3" name="">
             <a:extLst xmlns:a="http://schemas.openxmlformats.org/drawingml/2006/main">
               <a:ext uri="{FF2B5EF4-FFF2-40B4-BE49-F238E27FC236}">
-                <a16:creationId xmlns:a16="http://schemas.microsoft.com/office/drawing/2014/main" id="{958DB236-B4F4-44E6-A2FB-7E90B9EECB24}"/>
+                <a16:creationId xmlns:a16="http://schemas.microsoft.com/office/drawing/2014/main" id="{8CA51C5C-B6B4-43F2-906E-EAE0C07C4C90}"/>
               </a:ext>
             </a:extLst>
           </p:cNvPr>
@@ -2671,7 +2671,7 @@
           <p:nvPr/>
         </p:nvPicPr>
         <p:blipFill>
-          <a:blip xmlns:r="http://schemas.openxmlformats.org/officeDocument/2006/relationships" xmlns:a="http://schemas.openxmlformats.org/drawingml/2006/main" r:embed="R032d7cf6d9c24b33"/>
+          <a:blip xmlns:r="http://schemas.openxmlformats.org/officeDocument/2006/relationships" xmlns:a="http://schemas.openxmlformats.org/drawingml/2006/main" r:embed="R47944aef71544908"/>
           <a:stretch xmlns:a="http://schemas.openxmlformats.org/drawingml/2006/main"/>
         </p:blipFill>
         <p:spPr>
@@ -2687,7 +2687,7 @@
     </p:spTree>
     <p:extLst>
       <p:ext uri="{BB962C8B-B14F-4D97-AF65-F5344CB8AC3E}">
-        <p14:creationId xmlns:p14="http://schemas.microsoft.com/office/powerpoint/2010/main" val="2055409474"/>
+        <p14:creationId xmlns:p14="http://schemas.microsoft.com/office/powerpoint/2010/main" val="976622452"/>
       </p:ext>
     </p:extLst>
   </p:cSld>
@@ -2718,7 +2718,7 @@
           <p:cNvPr id="7" name="">
             <a:extLst xmlns:a="http://schemas.openxmlformats.org/drawingml/2006/main">
               <a:ext uri="{FF2B5EF4-FFF2-40B4-BE49-F238E27FC236}">
-                <a16:creationId xmlns:a16="http://schemas.microsoft.com/office/drawing/2014/main" id="{38BB98FC-333C-41B3-A30D-6D774856943B}"/>
+                <a16:creationId xmlns:a16="http://schemas.microsoft.com/office/drawing/2014/main" id="{79074EC7-25B3-43E7-97D2-C4B6EBC53AFA}"/>
               </a:ext>
             </a:extLst>
           </p:cNvPr>
@@ -2775,7 +2775,7 @@
           <p:cNvPr id="2" name="">
             <a:extLst xmlns:a="http://schemas.openxmlformats.org/drawingml/2006/main">
               <a:ext uri="{FF2B5EF4-FFF2-40B4-BE49-F238E27FC236}">
-                <a16:creationId xmlns:a16="http://schemas.microsoft.com/office/drawing/2014/main" id="{8A465CFB-1C34-4C89-BDE8-BFC3E01C150D}"/>
+                <a16:creationId xmlns:a16="http://schemas.microsoft.com/office/drawing/2014/main" id="{FFF9289C-2F7E-44FA-97D9-3C037C77806D}"/>
               </a:ext>
             </a:extLst>
           </p:cNvPr>
@@ -2836,7 +2836,7 @@
           <p:nvPr/>
         </p:nvPicPr>
         <p:blipFill>
-          <a:blip xmlns:r="http://schemas.openxmlformats.org/officeDocument/2006/relationships" xmlns:a="http://schemas.openxmlformats.org/drawingml/2006/main" r:embed="R5f7ec18dbbb54ac6"/>
+          <a:blip xmlns:r="http://schemas.openxmlformats.org/officeDocument/2006/relationships" xmlns:a="http://schemas.openxmlformats.org/drawingml/2006/main" r:embed="Re2f67c80742e4d2f"/>
           <a:stretch xmlns:a="http://schemas.openxmlformats.org/drawingml/2006/main"/>
         </p:blipFill>
         <p:spPr>
@@ -2854,7 +2854,7 @@
           <p:cNvPr id="4" name="">
             <a:extLst xmlns:a="http://schemas.openxmlformats.org/drawingml/2006/main">
               <a:ext uri="{FF2B5EF4-FFF2-40B4-BE49-F238E27FC236}">
-                <a16:creationId xmlns:a16="http://schemas.microsoft.com/office/drawing/2014/main" id="{8D5F9ACE-090D-4104-87EF-ADB22A65D38C}"/>
+                <a16:creationId xmlns:a16="http://schemas.microsoft.com/office/drawing/2014/main" id="{C77E9BD9-6491-40DF-86F7-125CD5ADBE13}"/>
               </a:ext>
             </a:extLst>
           </p:cNvPr>
@@ -2934,7 +2934,7 @@
           <p:cNvPr id="5" name="">
             <a:extLst xmlns:a="http://schemas.openxmlformats.org/drawingml/2006/main">
               <a:ext uri="{FF2B5EF4-FFF2-40B4-BE49-F238E27FC236}">
-                <a16:creationId xmlns:a16="http://schemas.microsoft.com/office/drawing/2014/main" id="{391D5121-FF47-43EF-8366-2DCDBBC26C09}"/>
+                <a16:creationId xmlns:a16="http://schemas.microsoft.com/office/drawing/2014/main" id="{A76D7DEC-2E00-43F2-8353-1B2374DE749C}"/>
               </a:ext>
             </a:extLst>
           </p:cNvPr>
@@ -3014,7 +3014,7 @@
           <p:cNvPr id="6" name="">
             <a:extLst xmlns:a="http://schemas.openxmlformats.org/drawingml/2006/main">
               <a:ext uri="{FF2B5EF4-FFF2-40B4-BE49-F238E27FC236}">
-                <a16:creationId xmlns:a16="http://schemas.microsoft.com/office/drawing/2014/main" id="{8BF16226-9135-4BD3-8ABE-DE684B79D990}"/>
+                <a16:creationId xmlns:a16="http://schemas.microsoft.com/office/drawing/2014/main" id="{D062FA10-3B5A-4893-B74F-4EAFAFCCA20A}"/>
               </a:ext>
             </a:extLst>
           </p:cNvPr>
@@ -3092,7 +3092,7 @@
     </p:spTree>
     <p:extLst>
       <p:ext uri="{BB962C8B-B14F-4D97-AF65-F5344CB8AC3E}">
-        <p14:creationId xmlns:p14="http://schemas.microsoft.com/office/powerpoint/2010/main" val="293090638"/>
+        <p14:creationId xmlns:p14="http://schemas.microsoft.com/office/powerpoint/2010/main" val="753984639"/>
       </p:ext>
     </p:extLst>
   </p:cSld>
@@ -3123,7 +3123,7 @@
           <p:cNvPr id="8" name="">
             <a:extLst xmlns:a="http://schemas.openxmlformats.org/drawingml/2006/main">
               <a:ext uri="{FF2B5EF4-FFF2-40B4-BE49-F238E27FC236}">
-                <a16:creationId xmlns:a16="http://schemas.microsoft.com/office/drawing/2014/main" id="{5C6CFAD0-36D1-46D7-8B7F-9A3460DCED45}"/>
+                <a16:creationId xmlns:a16="http://schemas.microsoft.com/office/drawing/2014/main" id="{79EBC3D8-6F61-46A0-BD4F-8053E9435C33}"/>
               </a:ext>
             </a:extLst>
           </p:cNvPr>
@@ -3180,7 +3180,7 @@
           <p:cNvPr id="2" name="">
             <a:extLst xmlns:a="http://schemas.openxmlformats.org/drawingml/2006/main">
               <a:ext uri="{FF2B5EF4-FFF2-40B4-BE49-F238E27FC236}">
-                <a16:creationId xmlns:a16="http://schemas.microsoft.com/office/drawing/2014/main" id="{FBE0DFE2-5053-4599-B5F5-03CB9A7B9E0D}"/>
+                <a16:creationId xmlns:a16="http://schemas.microsoft.com/office/drawing/2014/main" id="{64F0118B-86D8-44BD-ACA8-A68FADE765A9}"/>
               </a:ext>
             </a:extLst>
           </p:cNvPr>
@@ -3237,7 +3237,7 @@
           <p:cNvPr id="3" name="">
             <a:extLst xmlns:a="http://schemas.openxmlformats.org/drawingml/2006/main">
               <a:ext uri="{FF2B5EF4-FFF2-40B4-BE49-F238E27FC236}">
-                <a16:creationId xmlns:a16="http://schemas.microsoft.com/office/drawing/2014/main" id="{1AE83888-17B9-4F58-A10F-7D526374D3ED}"/>
+                <a16:creationId xmlns:a16="http://schemas.microsoft.com/office/drawing/2014/main" id="{E18B9E16-A8D7-45CF-A420-E16B13903EC6}"/>
               </a:ext>
             </a:extLst>
           </p:cNvPr>
@@ -3294,7 +3294,7 @@
           <p:cNvPr id="4" name="">
             <a:extLst xmlns:a="http://schemas.openxmlformats.org/drawingml/2006/main">
               <a:ext uri="{FF2B5EF4-FFF2-40B4-BE49-F238E27FC236}">
-                <a16:creationId xmlns:a16="http://schemas.microsoft.com/office/drawing/2014/main" id="{8828E24C-1EC2-4E3B-B567-429609451E6A}"/>
+                <a16:creationId xmlns:a16="http://schemas.microsoft.com/office/drawing/2014/main" id="{FC78AA33-CC79-4B08-928C-6570905E991E}"/>
               </a:ext>
             </a:extLst>
           </p:cNvPr>
@@ -3397,7 +3397,7 @@
           <p:cNvPr id="5" name="">
             <a:extLst xmlns:a="http://schemas.openxmlformats.org/drawingml/2006/main">
               <a:ext uri="{FF2B5EF4-FFF2-40B4-BE49-F238E27FC236}">
-                <a16:creationId xmlns:a16="http://schemas.microsoft.com/office/drawing/2014/main" id="{73256DD2-A659-4E1A-AE9D-0E0B55538017}"/>
+                <a16:creationId xmlns:a16="http://schemas.microsoft.com/office/drawing/2014/main" id="{69DA2B50-0A80-44EC-9965-C20FB1304589}"/>
               </a:ext>
             </a:extLst>
           </p:cNvPr>
@@ -3454,7 +3454,7 @@
           <p:cNvPr id="6" name="">
             <a:extLst xmlns:a="http://schemas.openxmlformats.org/drawingml/2006/main">
               <a:ext uri="{FF2B5EF4-FFF2-40B4-BE49-F238E27FC236}">
-                <a16:creationId xmlns:a16="http://schemas.microsoft.com/office/drawing/2014/main" id="{FF032160-83B8-42FC-9141-8E5A93B7D0AA}"/>
+                <a16:creationId xmlns:a16="http://schemas.microsoft.com/office/drawing/2014/main" id="{BE4F28EA-9792-4689-A035-AA5F6E92E173}"/>
               </a:ext>
             </a:extLst>
           </p:cNvPr>
@@ -3557,7 +3557,7 @@
           <p:cNvPr id="7" name="">
             <a:extLst xmlns:a="http://schemas.openxmlformats.org/drawingml/2006/main">
               <a:ext uri="{FF2B5EF4-FFF2-40B4-BE49-F238E27FC236}">
-                <a16:creationId xmlns:a16="http://schemas.microsoft.com/office/drawing/2014/main" id="{A9FD63EF-D072-4919-B260-5D2CCD0D98C5}"/>
+                <a16:creationId xmlns:a16="http://schemas.microsoft.com/office/drawing/2014/main" id="{6E251921-0966-4E07-8BE5-33CD6A93116A}"/>
               </a:ext>
             </a:extLst>
           </p:cNvPr>
@@ -3612,7 +3612,7 @@
     </p:spTree>
     <p:extLst>
       <p:ext uri="{BB962C8B-B14F-4D97-AF65-F5344CB8AC3E}">
-        <p14:creationId xmlns:p14="http://schemas.microsoft.com/office/powerpoint/2010/main" val="1113822546"/>
+        <p14:creationId xmlns:p14="http://schemas.microsoft.com/office/powerpoint/2010/main" val="1167802534"/>
       </p:ext>
     </p:extLst>
   </p:cSld>

</xml_diff>